<commit_message>
Initial commit - adding SmartPlate Data Mining project files
</commit_message>
<xml_diff>
--- a/docs/Smart_Food_Waste_Management_Presentation.pptx
+++ b/docs/Smart_Food_Waste_Management_Presentation.pptx
@@ -8728,7 +8728,7 @@
           </a:prstGeom>
           <a:extLst>
             <a:ext uri="{C572A759-6A51-4108-AA02-DFA0A04FC94B}">
-              <ma14:wrappingTextBoxFlag xmlns="" xmlns:ma14="http://schemas.microsoft.com/office/mac/drawingml/2011/main" val="0"/>
+              <ma14:wrappingTextBoxFlag xmlns:ma14="http://schemas.microsoft.com/office/mac/drawingml/2011/main" xmlns="" val="0"/>
             </a:ext>
           </a:extLst>
         </p:spPr>
@@ -8859,7 +8859,7 @@
           </a:prstGeom>
           <a:extLst>
             <a:ext uri="{C572A759-6A51-4108-AA02-DFA0A04FC94B}">
-              <ma14:wrappingTextBoxFlag xmlns="" xmlns:ma14="http://schemas.microsoft.com/office/mac/drawingml/2011/main" val="0"/>
+              <ma14:wrappingTextBoxFlag xmlns:ma14="http://schemas.microsoft.com/office/mac/drawingml/2011/main" xmlns="" val="0"/>
             </a:ext>
           </a:extLst>
         </p:spPr>
@@ -8934,7 +8934,7 @@
           </a:prstGeom>
           <a:extLst>
             <a:ext uri="{C572A759-6A51-4108-AA02-DFA0A04FC94B}">
-              <ma14:wrappingTextBoxFlag xmlns="" xmlns:ma14="http://schemas.microsoft.com/office/mac/drawingml/2011/main" val="0"/>
+              <ma14:wrappingTextBoxFlag xmlns:ma14="http://schemas.microsoft.com/office/mac/drawingml/2011/main" xmlns="" val="0"/>
             </a:ext>
           </a:extLst>
         </p:spPr>
@@ -10572,7 +10572,7 @@
           </a:prstGeom>
           <a:extLst>
             <a:ext uri="{C572A759-6A51-4108-AA02-DFA0A04FC94B}">
-              <ma14:wrappingTextBoxFlag xmlns="" xmlns:ma14="http://schemas.microsoft.com/office/mac/drawingml/2011/main" val="0"/>
+              <ma14:wrappingTextBoxFlag xmlns:ma14="http://schemas.microsoft.com/office/mac/drawingml/2011/main" xmlns="" val="0"/>
             </a:ext>
           </a:extLst>
         </p:spPr>
@@ -10721,9 +10721,104 @@
           </a:p>
         </p:txBody>
       </p:sp>
+      <p:sp>
+        <p:nvSpPr>
+          <p:cNvPr id="17" name="Dashboard views"/>
+          <p:cNvSpPr txBox="1"/>
+          <p:nvPr/>
+        </p:nvSpPr>
+        <p:spPr>
+          <a:xfrm>
+            <a:off x="457200" y="4234282"/>
+            <a:ext cx="8229600" cy="420000"/>
+          </a:xfrm>
+          <a:prstGeom prst="rect">
+            <a:avLst/>
+          </a:prstGeom>
+          <a:noFill/>
+          <a:ln/>
+        </p:spPr>
+        <p:txBody>
+          <a:bodyPr wrap="square" lIns="0" tIns="0" rIns="0" bIns="0" rtlCol="0" anchor="t"/>
+          <a:lstStyle/>
+          <a:p>
+            <a:pPr marL="0" indent="0">
+              <a:buNone/>
+            </a:pPr>
+            <a:r>
+              <a:rPr lang="en-US" sz="1200" b="1" dirty="0">
+                <a:solidFill>
+                  <a:schemeClr val="tx2"/>
+                </a:solidFill>
+              </a:rPr>
+              <a:t>Dashboard views: </a:t>
+            </a:r>
+            <a:r>
+              <a:rPr lang="en-US" sz="1200" dirty="0">
+                <a:solidFill>
+                  <a:schemeClr val="tx1"/>
+                </a:solidFill>
+              </a:rPr>
+              <a:t>Total Prepared, Sold, Wasted • Waste % • Average Predicted Demand • Food Waste by Category • Top Food Items by Waste • Prepared vs Sold vs Wasted • Regression results • Apriori association rules</a:t>
+            </a:r>
+            <a:endParaRPr lang="en-US" sz="1200" dirty="0"/>
+          </a:p>
+        </p:txBody>
+      </p:sp>
+      <p:sp>
+        <p:nvSpPr>
+          <p:cNvPr id="25" name="Slide Number Placeholder 0"/>
+          <p:cNvSpPr>
+            <a:spLocks noGrp="1"/>
+          </p:cNvSpPr>
+          <p:nvPr>
+            <p:ph type="sldNum" sz="quarter" idx="4294967295"/>
+          </p:nvPr>
+        </p:nvSpPr>
+        <p:spPr>
+          <a:xfrm>
+            <a:off x="8229600" y="4800600"/>
+            <a:ext cx="457200" cy="228600"/>
+          </a:xfrm>
+          <a:prstGeom prst="rect">
+            <a:avLst/>
+          </a:prstGeom>
+          <a:extLst>
+            <a:ext uri="{C572A759-6A51-4108-AA02-DFA0A04FC94B}">
+              <ma14:wrappingTextBoxFlag xmlns:ma14="http://schemas.microsoft.com/office/mac/drawingml/2011/main" xmlns="" val="0"/>
+            </a:ext>
+          </a:extLst>
+        </p:spPr>
+        <p:txBody>
+          <a:bodyPr/>
+          <a:lstStyle>
+            <a:lvl1pPr>
+              <a:defRPr sz="900">
+                <a:solidFill>
+                  <a:schemeClr val="accent4"/>
+                </a:solidFill>
+              </a:defRPr>
+            </a:lvl1pPr>
+          </a:lstStyle>
+          <a:p>
+            <a:pPr algn="r"/>
+            <a:fld id="{F7021451-1387-4CA6-816F-3879F97B5CBC}" type="slidenum">
+              <a:rPr lang="en-US" b="0"/>
+              <a:t>11</a:t>
+            </a:fld>
+            <a:endParaRPr lang="en-US"/>
+          </a:p>
+        </p:txBody>
+      </p:sp>
       <p:pic>
         <p:nvPicPr>
-          <p:cNvPr id="30" name="Power BI dashboard" descr="Power BI Smart Food Waste Management dashboard showing KPIs, waste trends, category distribution and Apriori rules"/>
+          <p:cNvPr id="4" name="Picture 3">
+            <a:extLst>
+              <a:ext uri="{FF2B5EF4-FFF2-40B4-BE49-F238E27FC236}">
+                <a16:creationId xmlns:a16="http://schemas.microsoft.com/office/drawing/2014/main" id="{F374D143-28BC-EE46-D883-FA2BE22B24D3}"/>
+              </a:ext>
+            </a:extLst>
+          </p:cNvPr>
           <p:cNvPicPr>
             <a:picLocks noChangeAspect="1"/>
           </p:cNvPicPr>
@@ -10737,108 +10832,14 @@
         </p:blipFill>
         <p:spPr>
           <a:xfrm>
-            <a:off x="1188720" y="914400"/>
-            <a:ext cx="6766560" cy="3228442"/>
+            <a:off x="961614" y="914401"/>
+            <a:ext cx="6980603" cy="3173564"/>
           </a:xfrm>
           <a:prstGeom prst="rect">
             <a:avLst/>
           </a:prstGeom>
-          <a:ln w="12700">
-            <a:solidFill>
-              <a:schemeClr val="accent6"/>
-            </a:solidFill>
-          </a:ln>
         </p:spPr>
       </p:pic>
-      <p:sp>
-        <p:nvSpPr>
-          <p:cNvPr id="17" name="Dashboard views"/>
-          <p:cNvSpPr txBox="1"/>
-          <p:nvPr/>
-        </p:nvSpPr>
-        <p:spPr>
-          <a:xfrm>
-            <a:off x="457200" y="4234282"/>
-            <a:ext cx="8229600" cy="420000"/>
-          </a:xfrm>
-          <a:prstGeom prst="rect">
-            <a:avLst/>
-          </a:prstGeom>
-          <a:noFill/>
-          <a:ln/>
-        </p:spPr>
-        <p:txBody>
-          <a:bodyPr wrap="square" lIns="0" tIns="0" rIns="0" bIns="0" rtlCol="0" anchor="t"/>
-          <a:lstStyle/>
-          <a:p>
-            <a:pPr marL="0" indent="0">
-              <a:buNone/>
-            </a:pPr>
-            <a:r>
-              <a:rPr lang="en-US" sz="1200" b="1" dirty="0">
-                <a:solidFill>
-                  <a:schemeClr val="tx2"/>
-                </a:solidFill>
-              </a:rPr>
-              <a:t>Dashboard views: </a:t>
-            </a:r>
-            <a:r>
-              <a:rPr lang="en-US" sz="1200" dirty="0">
-                <a:solidFill>
-                  <a:schemeClr val="tx1"/>
-                </a:solidFill>
-              </a:rPr>
-              <a:t>Total Prepared, Sold, Wasted • Waste % • Average Predicted Demand • Food Waste by Category • Top Food Items by Waste • Prepared vs Sold vs Wasted • Regression results • Apriori association rules</a:t>
-            </a:r>
-            <a:endParaRPr lang="en-US" sz="1200" dirty="0"/>
-          </a:p>
-        </p:txBody>
-      </p:sp>
-      <p:sp>
-        <p:nvSpPr>
-          <p:cNvPr id="25" name="Slide Number Placeholder 0"/>
-          <p:cNvSpPr>
-            <a:spLocks noGrp="1"/>
-          </p:cNvSpPr>
-          <p:nvPr>
-            <p:ph type="sldNum" sz="quarter" idx="4294967295"/>
-          </p:nvPr>
-        </p:nvSpPr>
-        <p:spPr>
-          <a:xfrm>
-            <a:off x="8229600" y="4800600"/>
-            <a:ext cx="457200" cy="228600"/>
-          </a:xfrm>
-          <a:prstGeom prst="rect">
-            <a:avLst/>
-          </a:prstGeom>
-          <a:extLst>
-            <a:ext uri="{C572A759-6A51-4108-AA02-DFA0A04FC94B}">
-              <ma14:wrappingTextBoxFlag xmlns="" xmlns:ma14="http://schemas.microsoft.com/office/mac/drawingml/2011/main" val="0"/>
-            </a:ext>
-          </a:extLst>
-        </p:spPr>
-        <p:txBody>
-          <a:bodyPr/>
-          <a:lstStyle>
-            <a:lvl1pPr>
-              <a:defRPr sz="900">
-                <a:solidFill>
-                  <a:schemeClr val="accent4"/>
-                </a:solidFill>
-              </a:defRPr>
-            </a:lvl1pPr>
-          </a:lstStyle>
-          <a:p>
-            <a:pPr algn="r"/>
-            <a:fld id="{F7021451-1387-4CA6-816F-3879F97B5CBC}" type="slidenum">
-              <a:rPr lang="en-US" b="0"/>
-              <a:t>11</a:t>
-            </a:fld>
-            <a:endParaRPr lang="en-US"/>
-          </a:p>
-        </p:txBody>
-      </p:sp>
     </p:spTree>
   </p:cSld>
   <p:clrMapOvr>
@@ -12069,7 +12070,7 @@
           </a:prstGeom>
           <a:extLst>
             <a:ext uri="{C572A759-6A51-4108-AA02-DFA0A04FC94B}">
-              <ma14:wrappingTextBoxFlag xmlns="" xmlns:ma14="http://schemas.microsoft.com/office/mac/drawingml/2011/main" val="0"/>
+              <ma14:wrappingTextBoxFlag xmlns:ma14="http://schemas.microsoft.com/office/mac/drawingml/2011/main" xmlns="" val="0"/>
             </a:ext>
           </a:extLst>
         </p:spPr>
@@ -12521,7 +12522,7 @@
           </a:prstGeom>
           <a:extLst>
             <a:ext uri="{C572A759-6A51-4108-AA02-DFA0A04FC94B}">
-              <ma14:wrappingTextBoxFlag xmlns="" xmlns:ma14="http://schemas.microsoft.com/office/mac/drawingml/2011/main" val="0"/>
+              <ma14:wrappingTextBoxFlag xmlns:ma14="http://schemas.microsoft.com/office/mac/drawingml/2011/main" xmlns="" val="0"/>
             </a:ext>
           </a:extLst>
         </p:spPr>
@@ -13653,7 +13654,7 @@
           </a:prstGeom>
           <a:extLst>
             <a:ext uri="{C572A759-6A51-4108-AA02-DFA0A04FC94B}">
-              <ma14:wrappingTextBoxFlag xmlns="" xmlns:ma14="http://schemas.microsoft.com/office/mac/drawingml/2011/main" val="0"/>
+              <ma14:wrappingTextBoxFlag xmlns:ma14="http://schemas.microsoft.com/office/mac/drawingml/2011/main" xmlns="" val="0"/>
             </a:ext>
           </a:extLst>
         </p:spPr>
@@ -14492,7 +14493,7 @@
           </a:prstGeom>
           <a:extLst>
             <a:ext uri="{C572A759-6A51-4108-AA02-DFA0A04FC94B}">
-              <ma14:wrappingTextBoxFlag xmlns="" xmlns:ma14="http://schemas.microsoft.com/office/mac/drawingml/2011/main" val="0"/>
+              <ma14:wrappingTextBoxFlag xmlns:ma14="http://schemas.microsoft.com/office/mac/drawingml/2011/main" xmlns="" val="0"/>
             </a:ext>
           </a:extLst>
         </p:spPr>
@@ -18378,7 +18379,7 @@
           </a:prstGeom>
           <a:extLst>
             <a:ext uri="{C572A759-6A51-4108-AA02-DFA0A04FC94B}">
-              <ma14:wrappingTextBoxFlag xmlns="" xmlns:ma14="http://schemas.microsoft.com/office/mac/drawingml/2011/main" val="0"/>
+              <ma14:wrappingTextBoxFlag xmlns:ma14="http://schemas.microsoft.com/office/mac/drawingml/2011/main" xmlns="" val="0"/>
             </a:ext>
           </a:extLst>
         </p:spPr>
@@ -19290,7 +19291,7 @@
           </a:prstGeom>
           <a:extLst>
             <a:ext uri="{C572A759-6A51-4108-AA02-DFA0A04FC94B}">
-              <ma14:wrappingTextBoxFlag xmlns="" xmlns:ma14="http://schemas.microsoft.com/office/mac/drawingml/2011/main" val="0"/>
+              <ma14:wrappingTextBoxFlag xmlns:ma14="http://schemas.microsoft.com/office/mac/drawingml/2011/main" xmlns="" val="0"/>
             </a:ext>
           </a:extLst>
         </p:spPr>
@@ -20646,7 +20647,7 @@
           </a:prstGeom>
           <a:extLst>
             <a:ext uri="{C572A759-6A51-4108-AA02-DFA0A04FC94B}">
-              <ma14:wrappingTextBoxFlag xmlns="" xmlns:ma14="http://schemas.microsoft.com/office/mac/drawingml/2011/main" val="0"/>
+              <ma14:wrappingTextBoxFlag xmlns:ma14="http://schemas.microsoft.com/office/mac/drawingml/2011/main" xmlns="" val="0"/>
             </a:ext>
           </a:extLst>
         </p:spPr>
@@ -21306,7 +21307,7 @@
           </a:prstGeom>
           <a:extLst>
             <a:ext uri="{C572A759-6A51-4108-AA02-DFA0A04FC94B}">
-              <ma14:wrappingTextBoxFlag xmlns="" xmlns:ma14="http://schemas.microsoft.com/office/mac/drawingml/2011/main" val="0"/>
+              <ma14:wrappingTextBoxFlag xmlns:ma14="http://schemas.microsoft.com/office/mac/drawingml/2011/main" xmlns="" val="0"/>
             </a:ext>
           </a:extLst>
         </p:spPr>
@@ -22495,7 +22496,7 @@
           </a:prstGeom>
           <a:extLst>
             <a:ext uri="{C572A759-6A51-4108-AA02-DFA0A04FC94B}">
-              <ma14:wrappingTextBoxFlag xmlns="" xmlns:ma14="http://schemas.microsoft.com/office/mac/drawingml/2011/main" val="0"/>
+              <ma14:wrappingTextBoxFlag xmlns:ma14="http://schemas.microsoft.com/office/mac/drawingml/2011/main" xmlns="" val="0"/>
             </a:ext>
           </a:extLst>
         </p:spPr>
@@ -23102,7 +23103,7 @@
           </a:prstGeom>
           <a:extLst>
             <a:ext uri="{C572A759-6A51-4108-AA02-DFA0A04FC94B}">
-              <ma14:wrappingTextBoxFlag xmlns="" xmlns:ma14="http://schemas.microsoft.com/office/mac/drawingml/2011/main" val="0"/>
+              <ma14:wrappingTextBoxFlag xmlns:ma14="http://schemas.microsoft.com/office/mac/drawingml/2011/main" xmlns="" val="0"/>
             </a:ext>
           </a:extLst>
         </p:spPr>
@@ -24386,7 +24387,7 @@
           </a:prstGeom>
           <a:extLst>
             <a:ext uri="{C572A759-6A51-4108-AA02-DFA0A04FC94B}">
-              <ma14:wrappingTextBoxFlag xmlns="" xmlns:ma14="http://schemas.microsoft.com/office/mac/drawingml/2011/main" val="0"/>
+              <ma14:wrappingTextBoxFlag xmlns:ma14="http://schemas.microsoft.com/office/mac/drawingml/2011/main" xmlns="" val="0"/>
             </a:ext>
           </a:extLst>
         </p:spPr>

</xml_diff>